<commit_message>
Add English market copy starter
</commit_message>
<xml_diff>
--- a/docs/hackathon/slides.pptx
+++ b/docs/hackathon/slides.pptx
@@ -683,7 +683,7 @@
           <a:p>
             <a:r>
               <a:rPr lang="en-US" dirty="0"/>
-              <a:t>Demonstrate switching to PocketLedger, opening Markets, reviewing US/India/Japan launch plans, and showing Apple as not applicable to an Android app. These plans are editable templates, not researched SEO results or translations. Next, return to ReleaseProof demo and inspect its static security finding.</a:t>
+              <a:t>Demonstrate switching to PocketLedger, opening Markets, reviewing US/India/Japan launch plans, using the English starter-copy generator, and showing Apple as not applicable to an Android app. These plans are editable templates; search phrases are not researched and drafts need native translation. Next, return to ReleaseProof demo and inspect its static security finding.</a:t>
             </a:r>
             <a:endParaRPr lang="en-US" dirty="0"/>
           </a:p>
@@ -3594,7 +3594,7 @@
                 <a:ea typeface="Aptos" pitchFamily="34" charset="-122"/>
                 <a:cs typeface="Aptos" pitchFamily="34" charset="-120"/>
               </a:rPr>
-              <a:t>Edit listing fields and track search, artwork, privacy, and policy reviews.</a:t>
+              <a:t>Draft English listing copy; review search ideas, artwork, privacy, and policy.</a:t>
             </a:r>
             <a:endParaRPr lang="en-US" sz="1150" dirty="0"/>
           </a:p>

</xml_diff>

<commit_message>
Expand locale planning with CLDR catalogue
</commit_message>
<xml_diff>
--- a/docs/hackathon/slides.pptx
+++ b/docs/hackathon/slides.pptx
@@ -683,7 +683,7 @@
           <a:p>
             <a:r>
               <a:rPr lang="en-US" dirty="0"/>
-              <a:t>Demonstrate switching to PocketLedger, opening Markets, reviewing US/India/Japan launch plans, using the English starter-copy generator, and showing Apple as not applicable to an Android app. These plans are editable templates; search phrases are not researched and drafts need native translation. Next, return to ReleaseProof demo and inspect its static security finding.</a:t>
+              <a:t>Demonstrate switching to PocketLedger, opening Markets, searching the CLDR locale catalogue, adding India Hindi next to India English, generating English starter copy, and showing Apple as not applicable to an Android app. The 585 locales are suggestions; search phrases are not researched and drafts need native translation. Next, return to ReleaseProof demo and inspect its static security finding.</a:t>
             </a:r>
             <a:endParaRPr lang="en-US" dirty="0"/>
           </a:p>
@@ -3972,7 +3972,7 @@
                 <a:ea typeface="Aptos" pitchFamily="34" charset="-122"/>
                 <a:cs typeface="Aptos" pitchFamily="34" charset="-120"/>
               </a:rPr>
-              <a:t>6 starter locales</a:t>
+              <a:t>585 locale options</a:t>
             </a:r>
             <a:endParaRPr lang="en-US" sz="1300" dirty="0"/>
           </a:p>
@@ -4038,7 +4038,7 @@
                 <a:ea typeface="Aptos" pitchFamily="34" charset="-122"/>
                 <a:cs typeface="Aptos" pitchFamily="34" charset="-120"/>
               </a:rPr>
-              <a:t>Plan by app × country × channel</a:t>
+              <a:t>Plan by app × country × language × channel</a:t>
             </a:r>
             <a:endParaRPr lang="en-US" sz="1200" dirty="0"/>
           </a:p>

</xml_diff>

<commit_message>
Add bounded public repository scan and real IBM Bob evidence
</commit_message>
<xml_diff>
--- a/docs/hackathon/slides.pptx
+++ b/docs/hackathon/slides.pptx
@@ -771,7 +771,7 @@
           <a:p>
             <a:r>
               <a:rPr lang="en-US" dirty="0"/>
-              <a:t>Point out the blocked decision, source evidence and explicit unknowns. These counts describe the current local broken fixture only. Tests and builds did not run and compliance is not certified.</a:t>
+              <a:t>Point out the blocked decision, source evidence and explicit unknowns. These counts describe the current local broken fixture only. A real public GitHub repository can also be sampled in the browser, but its result has no score and does not establish complete security, store readiness, or compliance.</a:t>
             </a:r>
             <a:endParaRPr lang="en-US" dirty="0"/>
           </a:p>
@@ -947,7 +947,7 @@
           <a:p>
             <a:r>
               <a:rPr lang="en-US" dirty="0"/>
-              <a:t>Close by tying the working prototype to each judging dimension. The value statement is qualitative; there are no customer or productivity measurements. Before final submission, publish only the MIT-scoped additions, deploy the demo, obtain genuine IBM Bob session evidence, and record the narrated video.</a:t>
+              <a:t>Close by tying the working prototype to each judging dimension. The value statement is qualitative; there are no customer or productivity measurements. Before final submission, verify the public demo, obtain genuine IBM Bob session evidence, and record the narrated video.</a:t>
             </a:r>
             <a:endParaRPr lang="en-US" dirty="0"/>
           </a:p>
@@ -4641,7 +4641,7 @@
                 <a:ea typeface="Aptos" pitchFamily="34" charset="-122"/>
                 <a:cs typeface="Aptos" pitchFamily="34" charset="-120"/>
               </a:rPr>
-              <a:t>Tests and builds are not executed. Compliance is manual review or not assessed.</a:t>
+              <a:t>Fixture score only. Public GitHub scans are bounded and unscored; compliance remains unknown.</a:t>
             </a:r>
             <a:endParaRPr lang="en-US" sz="1100" dirty="0"/>
           </a:p>
@@ -5851,7 +5851,7 @@
                 <a:ea typeface="Aptos" pitchFamily="34" charset="-122"/>
                 <a:cs typeface="Aptos" pitchFamily="34" charset="-120"/>
               </a:rPr>
-              <a:t>Deterministic static checks, source evidence, redaction and portable reports.</a:t>
+              <a:t>Public GitHub intake, bounded static checks, source evidence and reports.</a:t>
             </a:r>
             <a:endParaRPr lang="en-US" sz="1300" dirty="0"/>
           </a:p>
@@ -5991,7 +5991,7 @@
                 <a:ea typeface="Aptos" pitchFamily="34" charset="-122"/>
                 <a:cs typeface="Aptos" pitchFamily="34" charset="-120"/>
               </a:rPr>
-              <a:t>A live broken fixture to audit to review to re-audit product walkthrough.</a:t>
+              <a:t>Live public source scan, global launch desk and broken-to-reviewed fixture flow.</a:t>
             </a:r>
             <a:endParaRPr lang="en-US" sz="1300" dirty="0"/>
           </a:p>
@@ -6382,7 +6382,7 @@
                 <a:ea typeface="Aptos" pitchFamily="34" charset="-122"/>
                 <a:cs typeface="Aptos" pitchFamily="34" charset="-120"/>
               </a:rPr>
-              <a:t>Publish MIT-scoped source  |  deploy demo  |  capture Bob sessions  |  record narrated video</a:t>
+              <a:t>Verify live source scan  |  capture real Bob sessions  |  record narrated video</a:t>
             </a:r>
             <a:endParaRPr lang="en-US" sz="1150" dirty="0"/>
           </a:p>

</xml_diff>